<commit_message>
se agregó estabilidad completa en modelo azul excepto en posicionamiento de código QR
</commit_message>
<xml_diff>
--- a/app/templates/universidad_2qrs/plantilla_diplomado.pptx
+++ b/app/templates/universidad_2qrs/plantilla_diplomado.pptx
@@ -119,23 +119,95 @@
 </p:presentation>
 </file>
 
+<file path=ppt/revisionInfo.xml><?xml version="1.0" encoding="utf-8"?>
+<p1510:revInfo xmlns:a="http://schemas.openxmlformats.org/drawingml/2006/main" xmlns:r="http://schemas.openxmlformats.org/officeDocument/2006/relationships" xmlns:p1510="http://schemas.microsoft.com/office/powerpoint/2015/10/main">
+  <p1510:revLst>
+    <p1510:client id="{2ECDD09E-9648-4DA4-91F7-7D06BC5A5820}" v="7" dt="2026-02-27T18:42:59.090"/>
+  </p1510:revLst>
+</p1510:revInfo>
+</file>
+
 <file path=ppt/changesInfos/changesInfo1.xml><?xml version="1.0" encoding="utf-8"?>
 <pc:chgInfo xmlns:a="http://schemas.openxmlformats.org/drawingml/2006/main" xmlns:r="http://schemas.openxmlformats.org/officeDocument/2006/relationships" xmlns:ac="http://schemas.microsoft.com/office/drawing/2013/main/command" xmlns:pc="http://schemas.microsoft.com/office/powerpoint/2013/main/command">
   <pc:docChgLst>
     <pc:chgData name="Benjamín de Jesús Cueva Niño de Guzmán" userId="56da303013910523" providerId="LiveId" clId="{532B7A48-8887-4F62-9537-0BA1FAE83637}"/>
-    <pc:docChg chg="custSel delSld modSld">
-      <pc:chgData name="Benjamín de Jesús Cueva Niño de Guzmán" userId="56da303013910523" providerId="LiveId" clId="{532B7A48-8887-4F62-9537-0BA1FAE83637}" dt="2026-01-14T23:39:32.441" v="15" actId="6549"/>
+    <pc:docChg chg="undo custSel delSld modSld">
+      <pc:chgData name="Benjamín de Jesús Cueva Niño de Guzmán" userId="56da303013910523" providerId="LiveId" clId="{532B7A48-8887-4F62-9537-0BA1FAE83637}" dt="2026-02-27T19:49:42.662" v="40"/>
       <pc:docMkLst>
         <pc:docMk/>
       </pc:docMkLst>
-      <pc:sldChg chg="delSp modSp mod">
-        <pc:chgData name="Benjamín de Jesús Cueva Niño de Guzmán" userId="56da303013910523" providerId="LiveId" clId="{532B7A48-8887-4F62-9537-0BA1FAE83637}" dt="2026-01-14T23:39:12.411" v="12" actId="1036"/>
+      <pc:sldChg chg="addSp delSp modSp mod">
+        <pc:chgData name="Benjamín de Jesús Cueva Niño de Guzmán" userId="56da303013910523" providerId="LiveId" clId="{532B7A48-8887-4F62-9537-0BA1FAE83637}" dt="2026-02-27T19:49:42.662" v="40"/>
         <pc:sldMkLst>
           <pc:docMk/>
           <pc:sldMk cId="2410626708" sldId="277"/>
         </pc:sldMkLst>
+        <pc:spChg chg="mod modVis">
+          <ac:chgData name="Benjamín de Jesús Cueva Niño de Guzmán" userId="56da303013910523" providerId="LiveId" clId="{532B7A48-8887-4F62-9537-0BA1FAE83637}" dt="2026-02-27T18:41:40.971" v="22" actId="14429"/>
+          <ac:spMkLst>
+            <pc:docMk/>
+            <pc:sldMk cId="2410626708" sldId="277"/>
+            <ac:spMk id="2" creationId="{6718E74D-9F2C-B892-E699-1EC198F4A308}"/>
+          </ac:spMkLst>
+        </pc:spChg>
         <pc:spChg chg="mod">
-          <ac:chgData name="Benjamín de Jesús Cueva Niño de Guzmán" userId="56da303013910523" providerId="LiveId" clId="{532B7A48-8887-4F62-9537-0BA1FAE83637}" dt="2026-01-14T23:39:12.411" v="12" actId="1036"/>
+          <ac:chgData name="Benjamín de Jesús Cueva Niño de Guzmán" userId="56da303013910523" providerId="LiveId" clId="{532B7A48-8887-4F62-9537-0BA1FAE83637}" dt="2026-02-27T18:42:45.760" v="30" actId="962"/>
+          <ac:spMkLst>
+            <pc:docMk/>
+            <pc:sldMk cId="2410626708" sldId="277"/>
+            <ac:spMk id="3" creationId="{0F11DFEA-FC46-1F41-8C5B-EA3E3C6BE3C1}"/>
+          </ac:spMkLst>
+        </pc:spChg>
+        <pc:spChg chg="add del mod">
+          <ac:chgData name="Benjamín de Jesús Cueva Niño de Guzmán" userId="56da303013910523" providerId="LiveId" clId="{532B7A48-8887-4F62-9537-0BA1FAE83637}" dt="2026-02-27T19:49:42.662" v="40"/>
+          <ac:spMkLst>
+            <pc:docMk/>
+            <pc:sldMk cId="2410626708" sldId="277"/>
+            <ac:spMk id="6" creationId="{D3A49D29-7E2E-6432-7436-A1B8CDE0CBD2}"/>
+          </ac:spMkLst>
+        </pc:spChg>
+        <pc:spChg chg="mod">
+          <ac:chgData name="Benjamín de Jesús Cueva Niño de Guzmán" userId="56da303013910523" providerId="LiveId" clId="{532B7A48-8887-4F62-9537-0BA1FAE83637}" dt="2026-02-27T18:42:19.873" v="28" actId="962"/>
+          <ac:spMkLst>
+            <pc:docMk/>
+            <pc:sldMk cId="2410626708" sldId="277"/>
+            <ac:spMk id="7" creationId="{F36D8880-B179-580E-0319-C4E9487E072A}"/>
+          </ac:spMkLst>
+        </pc:spChg>
+        <pc:spChg chg="del">
+          <ac:chgData name="Benjamín de Jesús Cueva Niño de Guzmán" userId="56da303013910523" providerId="LiveId" clId="{532B7A48-8887-4F62-9537-0BA1FAE83637}" dt="2026-02-27T18:39:58.557" v="16" actId="478"/>
+          <ac:spMkLst>
+            <pc:docMk/>
+            <pc:sldMk cId="2410626708" sldId="277"/>
+            <ac:spMk id="9" creationId="{86ED2EAC-2620-F68F-6D60-F89352D5B692}"/>
+          </ac:spMkLst>
+        </pc:spChg>
+        <pc:spChg chg="mod">
+          <ac:chgData name="Benjamín de Jesús Cueva Niño de Guzmán" userId="56da303013910523" providerId="LiveId" clId="{532B7A48-8887-4F62-9537-0BA1FAE83637}" dt="2026-02-27T18:42:59.090" v="31" actId="962"/>
+          <ac:spMkLst>
+            <pc:docMk/>
+            <pc:sldMk cId="2410626708" sldId="277"/>
+            <ac:spMk id="17" creationId="{FC88E61B-8665-F7AA-FB48-82299D51180D}"/>
+          </ac:spMkLst>
+        </pc:spChg>
+        <pc:spChg chg="mod">
+          <ac:chgData name="Benjamín de Jesús Cueva Niño de Guzmán" userId="56da303013910523" providerId="LiveId" clId="{532B7A48-8887-4F62-9537-0BA1FAE83637}" dt="2026-02-27T18:42:31.865" v="29" actId="962"/>
+          <ac:spMkLst>
+            <pc:docMk/>
+            <pc:sldMk cId="2410626708" sldId="277"/>
+            <ac:spMk id="19" creationId="{991C4A27-894B-7257-8062-6F839343BAAD}"/>
+          </ac:spMkLst>
+        </pc:spChg>
+        <pc:spChg chg="del">
+          <ac:chgData name="Benjamín de Jesús Cueva Niño de Guzmán" userId="56da303013910523" providerId="LiveId" clId="{532B7A48-8887-4F62-9537-0BA1FAE83637}" dt="2026-02-27T18:40:10.970" v="17" actId="478"/>
+          <ac:spMkLst>
+            <pc:docMk/>
+            <pc:sldMk cId="2410626708" sldId="277"/>
+            <ac:spMk id="20" creationId="{44DA88D6-6D58-D67D-9408-1B4832F17825}"/>
+          </ac:spMkLst>
+        </pc:spChg>
+        <pc:spChg chg="mod">
+          <ac:chgData name="Benjamín de Jesús Cueva Niño de Guzmán" userId="56da303013910523" providerId="LiveId" clId="{532B7A48-8887-4F62-9537-0BA1FAE83637}" dt="2026-02-27T18:42:02.061" v="25"/>
           <ac:spMkLst>
             <pc:docMk/>
             <pc:sldMk cId="2410626708" sldId="277"/>
@@ -143,88 +215,68 @@
           </ac:spMkLst>
         </pc:spChg>
         <pc:spChg chg="mod">
-          <ac:chgData name="Benjamín de Jesús Cueva Niño de Guzmán" userId="56da303013910523" providerId="LiveId" clId="{532B7A48-8887-4F62-9537-0BA1FAE83637}" dt="2026-01-14T23:39:12.411" v="12" actId="1036"/>
+          <ac:chgData name="Benjamín de Jesús Cueva Niño de Guzmán" userId="56da303013910523" providerId="LiveId" clId="{532B7A48-8887-4F62-9537-0BA1FAE83637}" dt="2026-02-27T18:42:03.214" v="26"/>
           <ac:spMkLst>
             <pc:docMk/>
             <pc:sldMk cId="2410626708" sldId="277"/>
             <ac:spMk id="23" creationId="{D962536F-CB9F-1938-8F28-5D8C8FE943C7}"/>
           </ac:spMkLst>
         </pc:spChg>
-        <pc:picChg chg="del">
-          <ac:chgData name="Benjamín de Jesús Cueva Niño de Guzmán" userId="56da303013910523" providerId="LiveId" clId="{532B7A48-8887-4F62-9537-0BA1FAE83637}" dt="2026-01-14T23:39:07" v="4" actId="478"/>
+        <pc:picChg chg="mod">
+          <ac:chgData name="Benjamín de Jesús Cueva Niño de Guzmán" userId="56da303013910523" providerId="LiveId" clId="{532B7A48-8887-4F62-9537-0BA1FAE83637}" dt="2026-02-27T18:42:00.579" v="24"/>
           <ac:picMkLst>
             <pc:docMk/>
             <pc:sldMk cId="2410626708" sldId="277"/>
-            <ac:picMk id="18" creationId="{65D7DBE5-F3CD-0E62-8756-B223F377361E}"/>
+            <ac:picMk id="4" creationId="{BC1BF896-3A0A-2D18-2C55-A99B63C83C9E}"/>
+          </ac:picMkLst>
+        </pc:picChg>
+        <pc:picChg chg="mod">
+          <ac:chgData name="Benjamín de Jesús Cueva Niño de Guzmán" userId="56da303013910523" providerId="LiveId" clId="{532B7A48-8887-4F62-9537-0BA1FAE83637}" dt="2026-02-27T18:43:13.475" v="35"/>
+          <ac:picMkLst>
+            <pc:docMk/>
+            <pc:sldMk cId="2410626708" sldId="277"/>
+            <ac:picMk id="5" creationId="{E8D55156-67B8-4336-A410-DB422B06644F}"/>
+          </ac:picMkLst>
+        </pc:picChg>
+        <pc:picChg chg="mod">
+          <ac:chgData name="Benjamín de Jesús Cueva Niño de Guzmán" userId="56da303013910523" providerId="LiveId" clId="{532B7A48-8887-4F62-9537-0BA1FAE83637}" dt="2026-02-27T18:42:06.294" v="27"/>
+          <ac:picMkLst>
+            <pc:docMk/>
+            <pc:sldMk cId="2410626708" sldId="277"/>
+            <ac:picMk id="8" creationId="{E620381B-4FC1-7AC1-6064-1BDB1EDD40BC}"/>
+          </ac:picMkLst>
+        </pc:picChg>
+        <pc:picChg chg="mod">
+          <ac:chgData name="Benjamín de Jesús Cueva Niño de Guzmán" userId="56da303013910523" providerId="LiveId" clId="{532B7A48-8887-4F62-9537-0BA1FAE83637}" dt="2026-02-27T18:43:02.463" v="32"/>
+          <ac:picMkLst>
+            <pc:docMk/>
+            <pc:sldMk cId="2410626708" sldId="277"/>
+            <ac:picMk id="16" creationId="{B7718B06-55CA-2E3C-6C80-F4BE84446227}"/>
+          </ac:picMkLst>
+        </pc:picChg>
+        <pc:picChg chg="mod">
+          <ac:chgData name="Benjamín de Jesús Cueva Niño de Guzmán" userId="56da303013910523" providerId="LiveId" clId="{532B7A48-8887-4F62-9537-0BA1FAE83637}" dt="2026-02-27T18:43:10.965" v="34"/>
+          <ac:picMkLst>
+            <pc:docMk/>
+            <pc:sldMk cId="2410626708" sldId="277"/>
+            <ac:picMk id="21" creationId="{F747E739-70C9-F0BF-4A9E-62BD5CFA55FA}"/>
           </ac:picMkLst>
         </pc:picChg>
       </pc:sldChg>
-      <pc:sldChg chg="delSp modSp mod">
-        <pc:chgData name="Benjamín de Jesús Cueva Niño de Guzmán" userId="56da303013910523" providerId="LiveId" clId="{532B7A48-8887-4F62-9537-0BA1FAE83637}" dt="2026-01-14T23:39:32.441" v="15" actId="6549"/>
+      <pc:sldChg chg="modSp mod">
+        <pc:chgData name="Benjamín de Jesús Cueva Niño de Guzmán" userId="56da303013910523" providerId="LiveId" clId="{532B7A48-8887-4F62-9537-0BA1FAE83637}" dt="2026-02-27T18:40:25.918" v="18" actId="1036"/>
         <pc:sldMkLst>
           <pc:docMk/>
           <pc:sldMk cId="4084903007" sldId="278"/>
         </pc:sldMkLst>
-        <pc:spChg chg="mod">
-          <ac:chgData name="Benjamín de Jesús Cueva Niño de Guzmán" userId="56da303013910523" providerId="LiveId" clId="{532B7A48-8887-4F62-9537-0BA1FAE83637}" dt="2026-01-14T23:39:32.441" v="15" actId="6549"/>
-          <ac:spMkLst>
-            <pc:docMk/>
-            <pc:sldMk cId="4084903007" sldId="278"/>
-            <ac:spMk id="25" creationId="{1BD7C6F0-73B6-617B-0B21-594BAED95EBF}"/>
-          </ac:spMkLst>
-        </pc:spChg>
-        <pc:picChg chg="del">
-          <ac:chgData name="Benjamín de Jesús Cueva Niño de Guzmán" userId="56da303013910523" providerId="LiveId" clId="{532B7A48-8887-4F62-9537-0BA1FAE83637}" dt="2026-01-14T23:39:27.620" v="13" actId="478"/>
+        <pc:picChg chg="mod">
+          <ac:chgData name="Benjamín de Jesús Cueva Niño de Guzmán" userId="56da303013910523" providerId="LiveId" clId="{532B7A48-8887-4F62-9537-0BA1FAE83637}" dt="2026-02-27T18:40:25.918" v="18" actId="1036"/>
           <ac:picMkLst>
             <pc:docMk/>
             <pc:sldMk cId="4084903007" sldId="278"/>
-            <ac:picMk id="7" creationId="{1A5F3F7F-F6EA-295F-A298-EE7118A8FF90}"/>
+            <ac:picMk id="3" creationId="{7732230B-A029-72C0-9D5B-2705D3A02338}"/>
           </ac:picMkLst>
         </pc:picChg>
-        <pc:picChg chg="del">
-          <ac:chgData name="Benjamín de Jesús Cueva Niño de Guzmán" userId="56da303013910523" providerId="LiveId" clId="{532B7A48-8887-4F62-9537-0BA1FAE83637}" dt="2026-01-14T23:39:29.163" v="14" actId="478"/>
-          <ac:picMkLst>
-            <pc:docMk/>
-            <pc:sldMk cId="4084903007" sldId="278"/>
-            <ac:picMk id="17" creationId="{E2F7B553-0DD8-3254-E8A5-8AFCBCCE12B1}"/>
-          </ac:picMkLst>
-        </pc:picChg>
-        <pc:picChg chg="del">
-          <ac:chgData name="Benjamín de Jesús Cueva Niño de Guzmán" userId="56da303013910523" providerId="LiveId" clId="{532B7A48-8887-4F62-9537-0BA1FAE83637}" dt="2026-01-14T23:39:08.807" v="5" actId="478"/>
-          <ac:picMkLst>
-            <pc:docMk/>
-            <pc:sldMk cId="4084903007" sldId="278"/>
-            <ac:picMk id="26" creationId="{39C9745C-4A41-3AC5-CAAD-095724A20EBB}"/>
-          </ac:picMkLst>
-        </pc:picChg>
-      </pc:sldChg>
-      <pc:sldChg chg="del">
-        <pc:chgData name="Benjamín de Jesús Cueva Niño de Guzmán" userId="56da303013910523" providerId="LiveId" clId="{532B7A48-8887-4F62-9537-0BA1FAE83637}" dt="2026-01-14T23:38:56.402" v="2" actId="47"/>
-        <pc:sldMkLst>
-          <pc:docMk/>
-          <pc:sldMk cId="1379650257" sldId="279"/>
-        </pc:sldMkLst>
-      </pc:sldChg>
-      <pc:sldChg chg="del">
-        <pc:chgData name="Benjamín de Jesús Cueva Niño de Guzmán" userId="56da303013910523" providerId="LiveId" clId="{532B7A48-8887-4F62-9537-0BA1FAE83637}" dt="2026-01-14T23:38:56.766" v="3" actId="47"/>
-        <pc:sldMkLst>
-          <pc:docMk/>
-          <pc:sldMk cId="2353653050" sldId="280"/>
-        </pc:sldMkLst>
-      </pc:sldChg>
-      <pc:sldChg chg="del">
-        <pc:chgData name="Benjamín de Jesús Cueva Niño de Guzmán" userId="56da303013910523" providerId="LiveId" clId="{532B7A48-8887-4F62-9537-0BA1FAE83637}" dt="2026-01-14T23:38:55.858" v="0" actId="47"/>
-        <pc:sldMkLst>
-          <pc:docMk/>
-          <pc:sldMk cId="4178494260" sldId="281"/>
-        </pc:sldMkLst>
-      </pc:sldChg>
-      <pc:sldChg chg="del">
-        <pc:chgData name="Benjamín de Jesús Cueva Niño de Guzmán" userId="56da303013910523" providerId="LiveId" clId="{532B7A48-8887-4F62-9537-0BA1FAE83637}" dt="2026-01-14T23:38:56.003" v="1" actId="47"/>
-        <pc:sldMkLst>
-          <pc:docMk/>
-          <pc:sldMk cId="1741124028" sldId="282"/>
-        </pc:sldMkLst>
       </pc:sldChg>
     </pc:docChg>
   </pc:docChgLst>
@@ -313,7 +365,7 @@
           <a:p>
             <a:fld id="{03C7FEFC-EB52-44D6-B3F1-2A7BB7FA4226}" type="datetimeFigureOut">
               <a:rPr lang="es-PE" smtClean="0"/>
-              <a:t>2/02/2026</a:t>
+              <a:t>27/02/2026</a:t>
             </a:fld>
             <a:endParaRPr lang="es-PE" dirty="0"/>
           </a:p>
@@ -478,7 +530,7 @@
           <a:p>
             <a:fld id="{64955E78-CBAA-441B-9163-D9CD5E983BDA}" type="datetimeFigureOut">
               <a:rPr lang="en-US" smtClean="0"/>
-              <a:t>2/2/2026</a:t>
+              <a:t>2/27/2026</a:t>
             </a:fld>
             <a:endParaRPr lang="en-US" dirty="0"/>
           </a:p>
@@ -877,7 +929,7 @@
           <a:p>
             <a:fld id="{5C4C4E00-4716-4B48-9D97-535E4F94A274}" type="datetimeFigureOut">
               <a:rPr lang="es-PE" smtClean="0"/>
-              <a:t>2/02/2026</a:t>
+              <a:t>27/02/2026</a:t>
             </a:fld>
             <a:endParaRPr lang="es-PE" dirty="0"/>
           </a:p>
@@ -1047,7 +1099,7 @@
           <a:p>
             <a:fld id="{5C4C4E00-4716-4B48-9D97-535E4F94A274}" type="datetimeFigureOut">
               <a:rPr lang="es-PE" smtClean="0"/>
-              <a:t>2/02/2026</a:t>
+              <a:t>27/02/2026</a:t>
             </a:fld>
             <a:endParaRPr lang="es-PE" dirty="0"/>
           </a:p>
@@ -1227,7 +1279,7 @@
           <a:p>
             <a:fld id="{5C4C4E00-4716-4B48-9D97-535E4F94A274}" type="datetimeFigureOut">
               <a:rPr lang="es-PE" smtClean="0"/>
-              <a:t>2/02/2026</a:t>
+              <a:t>27/02/2026</a:t>
             </a:fld>
             <a:endParaRPr lang="es-PE" dirty="0"/>
           </a:p>
@@ -1397,7 +1449,7 @@
           <a:p>
             <a:fld id="{5C4C4E00-4716-4B48-9D97-535E4F94A274}" type="datetimeFigureOut">
               <a:rPr lang="es-PE" smtClean="0"/>
-              <a:t>2/02/2026</a:t>
+              <a:t>27/02/2026</a:t>
             </a:fld>
             <a:endParaRPr lang="es-PE" dirty="0"/>
           </a:p>
@@ -1641,7 +1693,7 @@
           <a:p>
             <a:fld id="{5C4C4E00-4716-4B48-9D97-535E4F94A274}" type="datetimeFigureOut">
               <a:rPr lang="es-PE" smtClean="0"/>
-              <a:t>2/02/2026</a:t>
+              <a:t>27/02/2026</a:t>
             </a:fld>
             <a:endParaRPr lang="es-PE" dirty="0"/>
           </a:p>
@@ -1873,7 +1925,7 @@
           <a:p>
             <a:fld id="{5C4C4E00-4716-4B48-9D97-535E4F94A274}" type="datetimeFigureOut">
               <a:rPr lang="es-PE" smtClean="0"/>
-              <a:t>2/02/2026</a:t>
+              <a:t>27/02/2026</a:t>
             </a:fld>
             <a:endParaRPr lang="es-PE" dirty="0"/>
           </a:p>
@@ -2240,7 +2292,7 @@
           <a:p>
             <a:fld id="{5C4C4E00-4716-4B48-9D97-535E4F94A274}" type="datetimeFigureOut">
               <a:rPr lang="es-PE" smtClean="0"/>
-              <a:t>2/02/2026</a:t>
+              <a:t>27/02/2026</a:t>
             </a:fld>
             <a:endParaRPr lang="es-PE" dirty="0"/>
           </a:p>
@@ -2358,7 +2410,7 @@
           <a:p>
             <a:fld id="{5C4C4E00-4716-4B48-9D97-535E4F94A274}" type="datetimeFigureOut">
               <a:rPr lang="es-PE" smtClean="0"/>
-              <a:t>2/02/2026</a:t>
+              <a:t>27/02/2026</a:t>
             </a:fld>
             <a:endParaRPr lang="es-PE" dirty="0"/>
           </a:p>
@@ -2453,7 +2505,7 @@
           <a:p>
             <a:fld id="{5C4C4E00-4716-4B48-9D97-535E4F94A274}" type="datetimeFigureOut">
               <a:rPr lang="es-PE" smtClean="0"/>
-              <a:t>2/02/2026</a:t>
+              <a:t>27/02/2026</a:t>
             </a:fld>
             <a:endParaRPr lang="es-PE" dirty="0"/>
           </a:p>
@@ -2730,7 +2782,7 @@
           <a:p>
             <a:fld id="{5C4C4E00-4716-4B48-9D97-535E4F94A274}" type="datetimeFigureOut">
               <a:rPr lang="es-PE" smtClean="0"/>
-              <a:t>2/02/2026</a:t>
+              <a:t>27/02/2026</a:t>
             </a:fld>
             <a:endParaRPr lang="es-PE" dirty="0"/>
           </a:p>
@@ -2987,7 +3039,7 @@
           <a:p>
             <a:fld id="{5C4C4E00-4716-4B48-9D97-535E4F94A274}" type="datetimeFigureOut">
               <a:rPr lang="es-PE" smtClean="0"/>
-              <a:t>2/02/2026</a:t>
+              <a:t>27/02/2026</a:t>
             </a:fld>
             <a:endParaRPr lang="es-PE" dirty="0"/>
           </a:p>
@@ -3200,7 +3252,7 @@
           <a:p>
             <a:fld id="{5C4C4E00-4716-4B48-9D97-535E4F94A274}" type="datetimeFigureOut">
               <a:rPr lang="es-PE" smtClean="0"/>
-              <a:t>2/02/2026</a:t>
+              <a:t>27/02/2026</a:t>
             </a:fld>
             <a:endParaRPr lang="es-PE" dirty="0"/>
           </a:p>
@@ -3621,7 +3673,7 @@
             </a:extLst>
           </p:cNvPr>
           <p:cNvPicPr>
-            <a:picLocks noChangeAspect="1"/>
+            <a:picLocks noGrp="1" noRot="1" noChangeAspect="1" noMove="1" noResize="1" noEditPoints="1" noAdjustHandles="1" noChangeArrowheads="1" noChangeShapeType="1" noCrop="1"/>
           </p:cNvPicPr>
           <p:nvPr/>
         </p:nvPicPr>
@@ -3656,7 +3708,7 @@
             </a:extLst>
           </p:cNvPr>
           <p:cNvPicPr>
-            <a:picLocks noChangeAspect="1"/>
+            <a:picLocks noGrp="1" noRot="1" noChangeAspect="1" noMove="1" noResize="1" noEditPoints="1" noAdjustHandles="1" noChangeArrowheads="1" noChangeShapeType="1" noCrop="1"/>
           </p:cNvPicPr>
           <p:nvPr/>
         </p:nvPicPr>
@@ -3684,7 +3736,7 @@
       </p:pic>
       <p:sp>
         <p:nvSpPr>
-          <p:cNvPr id="2" name="CuadroTexto 1">
+          <p:cNvPr id="2" name="PH_NOMBRES_APELLIDOS">
             <a:extLst>
               <a:ext uri="{FF2B5EF4-FFF2-40B4-BE49-F238E27FC236}">
                 <a16:creationId xmlns:a16="http://schemas.microsoft.com/office/drawing/2014/main" id="{6718E74D-9F2C-B892-E699-1EC198F4A308}"/>
@@ -3738,7 +3790,9 @@
               </a:ext>
             </a:extLst>
           </p:cNvPr>
-          <p:cNvSpPr txBox="1"/>
+          <p:cNvSpPr txBox="1">
+            <a:spLocks noGrp="1" noRot="1" noMove="1" noResize="1" noEditPoints="1" noAdjustHandles="1" noChangeArrowheads="1" noChangeShapeType="1"/>
+          </p:cNvSpPr>
           <p:nvPr/>
         </p:nvSpPr>
         <p:spPr>
@@ -3809,7 +3863,9 @@
               </a:ext>
             </a:extLst>
           </p:cNvPr>
-          <p:cNvPicPr/>
+          <p:cNvPicPr>
+            <a:picLocks noGrp="1" noRot="1" noMove="1" noResize="1" noEditPoints="1" noAdjustHandles="1" noChangeArrowheads="1" noChangeShapeType="1" noCrop="1"/>
+          </p:cNvPicPr>
           <p:nvPr/>
         </p:nvPicPr>
         <p:blipFill>
@@ -3851,7 +3907,7 @@
       </p:pic>
       <p:sp>
         <p:nvSpPr>
-          <p:cNvPr id="17" name="Rectángulo 16">
+          <p:cNvPr id="17" name="PH_TIPO_DOCUMENTO">
             <a:extLst>
               <a:ext uri="{FF2B5EF4-FFF2-40B4-BE49-F238E27FC236}">
                 <a16:creationId xmlns:a16="http://schemas.microsoft.com/office/drawing/2014/main" id="{FC88E61B-8665-F7AA-FB48-82299D51180D}"/>
@@ -3891,7 +3947,7 @@
       </p:sp>
       <p:sp>
         <p:nvSpPr>
-          <p:cNvPr id="3" name="Rectángulo 2">
+          <p:cNvPr id="3" name="PH_CONCEDIDO_A">
             <a:extLst>
               <a:ext uri="{FF2B5EF4-FFF2-40B4-BE49-F238E27FC236}">
                 <a16:creationId xmlns:a16="http://schemas.microsoft.com/office/drawing/2014/main" id="{0F11DFEA-FC46-1F41-8C5B-EA3E3C6BE3C1}"/>
@@ -3960,7 +4016,7 @@
       </p:sp>
       <p:sp>
         <p:nvSpPr>
-          <p:cNvPr id="19" name="Rectangle 60">
+          <p:cNvPr id="19" name="PH_CONTENIDO_PRINCIPAL">
             <a:extLst>
               <a:ext uri="{FF2B5EF4-FFF2-40B4-BE49-F238E27FC236}">
                 <a16:creationId xmlns:a16="http://schemas.microsoft.com/office/drawing/2014/main" id="{991C4A27-894B-7257-8062-6F839343BAAD}"/>
@@ -4214,7 +4270,7 @@
       </p:sp>
       <p:sp>
         <p:nvSpPr>
-          <p:cNvPr id="7" name="Rectángulo 6">
+          <p:cNvPr id="7" name="PH_FECHA_EMISION_LARGA">
             <a:extLst>
               <a:ext uri="{FF2B5EF4-FFF2-40B4-BE49-F238E27FC236}">
                 <a16:creationId xmlns:a16="http://schemas.microsoft.com/office/drawing/2014/main" id="{F36D8880-B179-580E-0319-C4E9487E072A}"/>
@@ -4263,57 +4319,6 @@
                 <a:prstClr val="black"/>
               </a:solidFill>
               <a:latin typeface="Times New Roman" panose="02020603050405020304" pitchFamily="18" charset="0"/>
-              <a:ea typeface="Cambria Math" panose="02040503050406030204" pitchFamily="18" charset="0"/>
-              <a:cs typeface="Times New Roman" panose="02020603050405020304" pitchFamily="18" charset="0"/>
-            </a:endParaRPr>
-          </a:p>
-        </p:txBody>
-      </p:sp>
-      <p:sp>
-        <p:nvSpPr>
-          <p:cNvPr id="20" name="Rectángulo 19">
-            <a:extLst>
-              <a:ext uri="{FF2B5EF4-FFF2-40B4-BE49-F238E27FC236}">
-                <a16:creationId xmlns:a16="http://schemas.microsoft.com/office/drawing/2014/main" id="{44DA88D6-6D58-D67D-9408-1B4832F17825}"/>
-              </a:ext>
-            </a:extLst>
-          </p:cNvPr>
-          <p:cNvSpPr/>
-          <p:nvPr/>
-        </p:nvSpPr>
-        <p:spPr>
-          <a:xfrm>
-            <a:off x="1071040" y="3342633"/>
-            <a:ext cx="5167704" cy="184666"/>
-          </a:xfrm>
-          <a:prstGeom prst="rect">
-            <a:avLst/>
-          </a:prstGeom>
-        </p:spPr>
-        <p:txBody>
-          <a:bodyPr wrap="square">
-            <a:spAutoFit/>
-          </a:bodyPr>
-          <a:lstStyle/>
-          <a:p>
-            <a:pPr algn="ctr">
-              <a:spcBef>
-                <a:spcPts val="415"/>
-              </a:spcBef>
-              <a:spcAft>
-                <a:spcPts val="415"/>
-              </a:spcAft>
-            </a:pPr>
-            <a:r>
-              <a:rPr lang="es-PE" sz="600" b="1" dirty="0">
-                <a:latin typeface="Cambria Math" panose="02040503050406030204" pitchFamily="18" charset="0"/>
-                <a:ea typeface="Cambria Math" panose="02040503050406030204" pitchFamily="18" charset="0"/>
-                <a:cs typeface="Times New Roman" panose="02020603050405020304" pitchFamily="18" charset="0"/>
-              </a:rPr>
-              <a:t> </a:t>
-            </a:r>
-            <a:endParaRPr lang="en-US" sz="900" b="1" dirty="0">
-              <a:latin typeface="Cambria Math" panose="02040503050406030204" pitchFamily="18" charset="0"/>
               <a:ea typeface="Cambria Math" panose="02040503050406030204" pitchFamily="18" charset="0"/>
               <a:cs typeface="Times New Roman" panose="02020603050405020304" pitchFamily="18" charset="0"/>
             </a:endParaRPr>
@@ -4330,7 +4335,7 @@
             </a:extLst>
           </p:cNvPr>
           <p:cNvPicPr>
-            <a:picLocks noChangeAspect="1"/>
+            <a:picLocks noGrp="1" noRot="1" noChangeAspect="1" noMove="1" noResize="1" noEditPoints="1" noAdjustHandles="1" noChangeArrowheads="1" noChangeShapeType="1" noCrop="1"/>
           </p:cNvPicPr>
           <p:nvPr/>
         </p:nvPicPr>
@@ -4364,7 +4369,9 @@
               </a:ext>
             </a:extLst>
           </p:cNvPr>
-          <p:cNvSpPr txBox="1"/>
+          <p:cNvSpPr txBox="1">
+            <a:spLocks noGrp="1" noRot="1" noMove="1" noResize="1" noEditPoints="1" noAdjustHandles="1" noChangeArrowheads="1" noChangeShapeType="1"/>
+          </p:cNvSpPr>
           <p:nvPr/>
         </p:nvSpPr>
         <p:spPr>
@@ -4413,7 +4420,9 @@
               </a:ext>
             </a:extLst>
           </p:cNvPr>
-          <p:cNvSpPr txBox="1"/>
+          <p:cNvSpPr txBox="1">
+            <a:spLocks noGrp="1" noRot="1" noMove="1" noResize="1" noEditPoints="1" noAdjustHandles="1" noChangeArrowheads="1" noChangeShapeType="1"/>
+          </p:cNvSpPr>
           <p:nvPr/>
         </p:nvSpPr>
         <p:spPr>
@@ -4453,51 +4462,6 @@
           </a:p>
         </p:txBody>
       </p:sp>
-      <p:sp>
-        <p:nvSpPr>
-          <p:cNvPr id="9" name="AutoShape 4" descr="blob:https://web.whatsapp.com/34fb4399-25ce-4206-a049-279514aee91f">
-            <a:extLst>
-              <a:ext uri="{FF2B5EF4-FFF2-40B4-BE49-F238E27FC236}">
-                <a16:creationId xmlns:a16="http://schemas.microsoft.com/office/drawing/2014/main" id="{86ED2EAC-2620-F68F-6D60-F89352D5B692}"/>
-              </a:ext>
-            </a:extLst>
-          </p:cNvPr>
-          <p:cNvSpPr>
-            <a:spLocks noChangeAspect="1" noChangeArrowheads="1"/>
-          </p:cNvSpPr>
-          <p:nvPr/>
-        </p:nvSpPr>
-        <p:spPr bwMode="auto">
-          <a:xfrm>
-            <a:off x="-893235" y="1427740"/>
-            <a:ext cx="4278942" cy="4278956"/>
-          </a:xfrm>
-          <a:prstGeom prst="rect">
-            <a:avLst/>
-          </a:prstGeom>
-          <a:noFill/>
-          <a:extLst>
-            <a:ext uri="{909E8E84-426E-40DD-AFC4-6F175D3DCCD1}">
-              <a14:hiddenFill xmlns:a14="http://schemas.microsoft.com/office/drawing/2010/main">
-                <a:solidFill>
-                  <a:srgbClr val="FFFFFF"/>
-                </a:solidFill>
-              </a14:hiddenFill>
-            </a:ext>
-          </a:extLst>
-        </p:spPr>
-        <p:txBody>
-          <a:bodyPr vert="horz" wrap="square" lIns="91440" tIns="45720" rIns="91440" bIns="45720" numCol="1" anchor="t" anchorCtr="0" compatLnSpc="1">
-            <a:prstTxWarp prst="textNoShape">
-              <a:avLst/>
-            </a:prstTxWarp>
-          </a:bodyPr>
-          <a:lstStyle/>
-          <a:p>
-            <a:endParaRPr lang="es-PE"/>
-          </a:p>
-        </p:txBody>
-      </p:sp>
       <p:pic>
         <p:nvPicPr>
           <p:cNvPr id="8" name="Imagen 7">
@@ -4508,7 +4472,7 @@
             </a:extLst>
           </p:cNvPr>
           <p:cNvPicPr>
-            <a:picLocks noChangeAspect="1"/>
+            <a:picLocks noGrp="1" noRot="1" noChangeAspect="1" noMove="1" noResize="1" noEditPoints="1" noAdjustHandles="1" noChangeArrowheads="1" noChangeShapeType="1" noCrop="1"/>
           </p:cNvPicPr>
           <p:nvPr/>
         </p:nvPicPr>
@@ -6553,7 +6517,7 @@
         </p:blipFill>
         <p:spPr>
           <a:xfrm>
-            <a:off x="1482184" y="9088243"/>
+            <a:off x="1482184" y="9101690"/>
             <a:ext cx="368250" cy="202914"/>
           </a:xfrm>
           <a:prstGeom prst="rect">

</xml_diff>